<commit_message>
(1) SimulatorModel.SimulatorOutputEventHandler(...) now sets self._log_record = None after notifying Observers. (2) Fixed some bugs in comments. (3) Updated Developer_Documentation.txt and uml_class_diagram.pptx to reflect move of simulator output Queue to SimulatorModel class.
</commit_message>
<xml_diff>
--- a/src/tkAppFramework/Documentation/uml_class_diagram.pptx
+++ b/src/tkAppFramework/Documentation/uml_class_diagram.pptx
@@ -259,7 +259,7 @@
           <a:p>
             <a:fld id="{A0EF08ED-980B-4F22-8337-D84B3D20D851}" type="datetimeFigureOut">
               <a:rPr lang="en-US" smtClean="0"/>
-              <a:t>11/20/2025</a:t>
+              <a:t>1/7/2026</a:t>
             </a:fld>
             <a:endParaRPr lang="en-US"/>
           </a:p>
@@ -457,7 +457,7 @@
           <a:p>
             <a:fld id="{A0EF08ED-980B-4F22-8337-D84B3D20D851}" type="datetimeFigureOut">
               <a:rPr lang="en-US" smtClean="0"/>
-              <a:t>11/20/2025</a:t>
+              <a:t>1/7/2026</a:t>
             </a:fld>
             <a:endParaRPr lang="en-US"/>
           </a:p>
@@ -665,7 +665,7 @@
           <a:p>
             <a:fld id="{A0EF08ED-980B-4F22-8337-D84B3D20D851}" type="datetimeFigureOut">
               <a:rPr lang="en-US" smtClean="0"/>
-              <a:t>11/20/2025</a:t>
+              <a:t>1/7/2026</a:t>
             </a:fld>
             <a:endParaRPr lang="en-US"/>
           </a:p>
@@ -863,7 +863,7 @@
           <a:p>
             <a:fld id="{A0EF08ED-980B-4F22-8337-D84B3D20D851}" type="datetimeFigureOut">
               <a:rPr lang="en-US" smtClean="0"/>
-              <a:t>11/20/2025</a:t>
+              <a:t>1/7/2026</a:t>
             </a:fld>
             <a:endParaRPr lang="en-US"/>
           </a:p>
@@ -1138,7 +1138,7 @@
           <a:p>
             <a:fld id="{A0EF08ED-980B-4F22-8337-D84B3D20D851}" type="datetimeFigureOut">
               <a:rPr lang="en-US" smtClean="0"/>
-              <a:t>11/20/2025</a:t>
+              <a:t>1/7/2026</a:t>
             </a:fld>
             <a:endParaRPr lang="en-US"/>
           </a:p>
@@ -1403,7 +1403,7 @@
           <a:p>
             <a:fld id="{A0EF08ED-980B-4F22-8337-D84B3D20D851}" type="datetimeFigureOut">
               <a:rPr lang="en-US" smtClean="0"/>
-              <a:t>11/20/2025</a:t>
+              <a:t>1/7/2026</a:t>
             </a:fld>
             <a:endParaRPr lang="en-US"/>
           </a:p>
@@ -1815,7 +1815,7 @@
           <a:p>
             <a:fld id="{A0EF08ED-980B-4F22-8337-D84B3D20D851}" type="datetimeFigureOut">
               <a:rPr lang="en-US" smtClean="0"/>
-              <a:t>11/20/2025</a:t>
+              <a:t>1/7/2026</a:t>
             </a:fld>
             <a:endParaRPr lang="en-US"/>
           </a:p>
@@ -1956,7 +1956,7 @@
           <a:p>
             <a:fld id="{A0EF08ED-980B-4F22-8337-D84B3D20D851}" type="datetimeFigureOut">
               <a:rPr lang="en-US" smtClean="0"/>
-              <a:t>11/20/2025</a:t>
+              <a:t>1/7/2026</a:t>
             </a:fld>
             <a:endParaRPr lang="en-US"/>
           </a:p>
@@ -2069,7 +2069,7 @@
           <a:p>
             <a:fld id="{A0EF08ED-980B-4F22-8337-D84B3D20D851}" type="datetimeFigureOut">
               <a:rPr lang="en-US" smtClean="0"/>
-              <a:t>11/20/2025</a:t>
+              <a:t>1/7/2026</a:t>
             </a:fld>
             <a:endParaRPr lang="en-US"/>
           </a:p>
@@ -2380,7 +2380,7 @@
           <a:p>
             <a:fld id="{A0EF08ED-980B-4F22-8337-D84B3D20D851}" type="datetimeFigureOut">
               <a:rPr lang="en-US" smtClean="0"/>
-              <a:t>11/20/2025</a:t>
+              <a:t>1/7/2026</a:t>
             </a:fld>
             <a:endParaRPr lang="en-US"/>
           </a:p>
@@ -2668,7 +2668,7 @@
           <a:p>
             <a:fld id="{A0EF08ED-980B-4F22-8337-D84B3D20D851}" type="datetimeFigureOut">
               <a:rPr lang="en-US" smtClean="0"/>
-              <a:t>11/20/2025</a:t>
+              <a:t>1/7/2026</a:t>
             </a:fld>
             <a:endParaRPr lang="en-US"/>
           </a:p>
@@ -2909,7 +2909,7 @@
           <a:p>
             <a:fld id="{A0EF08ED-980B-4F22-8337-D84B3D20D851}" type="datetimeFigureOut">
               <a:rPr lang="en-US" smtClean="0"/>
-              <a:t>11/20/2025</a:t>
+              <a:t>1/7/2026</a:t>
             </a:fld>
             <a:endParaRPr lang="en-US"/>
           </a:p>
@@ -7214,6 +7214,54 @@
               <a:schemeClr val="tx1"/>
             </a:solidFill>
             <a:tailEnd type="triangle" w="lg" len="med"/>
+          </a:ln>
+        </p:spPr>
+        <p:style>
+          <a:lnRef idx="2">
+            <a:schemeClr val="accent1"/>
+          </a:lnRef>
+          <a:fillRef idx="0">
+            <a:schemeClr val="accent1"/>
+          </a:fillRef>
+          <a:effectRef idx="1">
+            <a:schemeClr val="accent1"/>
+          </a:effectRef>
+          <a:fontRef idx="minor">
+            <a:schemeClr val="tx1"/>
+          </a:fontRef>
+        </p:style>
+      </p:cxnSp>
+      <p:cxnSp>
+        <p:nvCxnSpPr>
+          <p:cNvPr id="5" name="Connector: Elbow 4">
+            <a:extLst>
+              <a:ext uri="{FF2B5EF4-FFF2-40B4-BE49-F238E27FC236}">
+                <a16:creationId xmlns:a16="http://schemas.microsoft.com/office/drawing/2014/main" id="{4E0AC0D0-F4C2-15AE-4B3D-312D1C7E9E86}"/>
+              </a:ext>
+            </a:extLst>
+          </p:cNvPr>
+          <p:cNvCxnSpPr>
+            <a:cxnSpLocks/>
+            <a:stCxn id="127" idx="0"/>
+            <a:endCxn id="37" idx="2"/>
+          </p:cNvCxnSpPr>
+          <p:nvPr/>
+        </p:nvCxnSpPr>
+        <p:spPr>
+          <a:xfrm rot="5400000" flipH="1" flipV="1">
+            <a:off x="1665448" y="1754627"/>
+            <a:ext cx="3958437" cy="3454057"/>
+          </a:xfrm>
+          <a:prstGeom prst="bentConnector3">
+            <a:avLst>
+              <a:gd name="adj1" fmla="val 79791"/>
+            </a:avLst>
+          </a:prstGeom>
+          <a:ln>
+            <a:solidFill>
+              <a:schemeClr val="tx1"/>
+            </a:solidFill>
+            <a:tailEnd type="arrow" w="lg" len="med"/>
           </a:ln>
         </p:spPr>
         <p:style>

</xml_diff>